<commit_message>
Docs to v2.1 state; reprice to $49 Pro / $79 Team
- README: pipeline diagram (+primary sources, shared memory), project structure,
  roadmap through v2.1, next = SOC 2/SSO/MS calendar/mobile
- pipeline-spec: phasing marked shipped through v2.1, pricing updated
- Pitch deck: $49 pricing, unit-econ chart 49/12/37 (~75% margin), roadmap
  slide shows v2 TEAMS+SOURCES shipped, under-the-hood refreshed
- Business plan: $49/$79 tiers (Team shipped), ARPU/ARR/margin projections
  recomputed, market sizing $590M, status v2.1, funding milestones updated
</commit_message>
<xml_diff>
--- a/docs/salesrx-pitch-deck.pptx
+++ b/docs/salesrx-pitch-deck.pptx
@@ -235,13 +235,13 @@
                 <c:formatCode>General</c:formatCode>
                 <c:ptCount val="3"/>
                 <c:pt idx="0">
-                  <c:v>39</c:v>
+                  <c:v>49</c:v>
                 </c:pt>
                 <c:pt idx="1">
                   <c:v>12</c:v>
                 </c:pt>
                 <c:pt idx="2">
-                  <c:v>27</c:v>
+                  <c:v>37</c:v>
                 </c:pt>
               </c:numCache>
             </c:numRef>
@@ -1577,7 +1577,7 @@
           <a:p>
             <a:r>
               <a:rPr lang="en-US" dirty="0"/>
-              <a:t>COGS: enrichment $0.05-0.30 + signals $0.05-0.20 + LLM $0.10-0.40 per brief; ~30 briefs/rep/mo with caching =&gt; ~$12. Illustrative, not audited.</a:t>
+              <a:t>COGS: enrichment $0.05-0.30 + signals $0.05-0.20 + LLM $0.10-0.40 per brief; ~30 briefs/rep/mo with caching =&gt; ~$12 COGS on $49 Pro. Illustrative, not audited.</a:t>
             </a:r>
             <a:endParaRPr lang="en-US" dirty="0"/>
           </a:p>
@@ -2513,7 +2513,7 @@
                 <a:ea typeface="Arial" pitchFamily="34" charset="-122"/>
                 <a:cs typeface="Arial" pitchFamily="34" charset="-120"/>
               </a:rPr>
-              <a:t>v1.0 · MVP</a:t>
+              <a:t>v1 · CORE</a:t>
             </a:r>
             <a:endParaRPr lang="en-US" sz="1250" dirty="0"/>
           </a:p>
@@ -2579,7 +2579,7 @@
                 <a:ea typeface="Arial" pitchFamily="34" charset="-122"/>
                 <a:cs typeface="Arial" pitchFamily="34" charset="-120"/>
               </a:rPr>
-              <a:t>Live AI research briefs, NEPQ ladders, coaching tips</a:t>
+              <a:t>Live AI research briefs, NEPQ ladders, verified hiring signals, watchlist alerts</a:t>
             </a:r>
             <a:endParaRPr lang="en-US" sz="1100" dirty="0"/>
           </a:p>
@@ -2677,7 +2677,7 @@
                 <a:ea typeface="Arial" pitchFamily="34" charset="-122"/>
                 <a:cs typeface="Arial" pitchFamily="34" charset="-120"/>
               </a:rPr>
-              <a:t>v1.1 · SIGNALS</a:t>
+              <a:t>v1.2 · WORKFLOW</a:t>
             </a:r>
             <a:endParaRPr lang="en-US" sz="1250" dirty="0"/>
           </a:p>
@@ -2743,7 +2743,7 @@
                 <a:ea typeface="Arial" pitchFamily="34" charset="-122"/>
                 <a:cs typeface="Arial" pitchFamily="34" charset="-120"/>
               </a:rPr>
-              <a:t>Verified technographics + hiring data, watchlist with delta alerts</a:t>
+              <a:t>Calendar auto-brief, HubSpot sync, post-meeting memory loop, Docker deploy</a:t>
             </a:r>
             <a:endParaRPr lang="en-US" sz="1100" dirty="0"/>
           </a:p>
@@ -2841,7 +2841,7 @@
                 <a:ea typeface="Arial" pitchFamily="34" charset="-122"/>
                 <a:cs typeface="Arial" pitchFamily="34" charset="-120"/>
               </a:rPr>
-              <a:t>v1.2 · WORKFLOW</a:t>
+              <a:t>v2 · TEAMS + SOURCES</a:t>
             </a:r>
             <a:endParaRPr lang="en-US" sz="1250" dirty="0"/>
           </a:p>
@@ -2907,7 +2907,7 @@
                 <a:ea typeface="Arial" pitchFamily="34" charset="-122"/>
                 <a:cs typeface="Arial" pitchFamily="34" charset="-120"/>
               </a:rPr>
-              <a:t>Calendar auto-brief, HubSpot sync, post-meeting memory loop, Docker deploy</a:t>
+              <a:t>Workspaces with shared memory, Postgres, Google OAuth, Salesforce, SEC filings + press + earnings-call excerpts</a:t>
             </a:r>
             <a:endParaRPr lang="en-US" sz="1100" dirty="0"/>
           </a:p>
@@ -3005,7 +3005,7 @@
                 <a:ea typeface="Arial" pitchFamily="34" charset="-122"/>
                 <a:cs typeface="Arial" pitchFamily="34" charset="-120"/>
               </a:rPr>
-              <a:t>v2 · TEAMS</a:t>
+              <a:t>next · SCALE</a:t>
             </a:r>
             <a:endParaRPr lang="en-US" sz="1250" dirty="0"/>
           </a:p>
@@ -3071,7 +3071,7 @@
                 <a:ea typeface="Arial" pitchFamily="34" charset="-122"/>
                 <a:cs typeface="Arial" pitchFamily="34" charset="-120"/>
               </a:rPr>
-              <a:t>Multi-rep workspaces, shared memory, Postgres, OAuth calendars, Salesforce</a:t>
+              <a:t>SOC 2, enterprise SSO, Microsoft calendar, mobile battle card, design partners</a:t>
             </a:r>
             <a:endParaRPr lang="en-US" sz="1100" dirty="0"/>
           </a:p>
@@ -5955,7 +5955,7 @@
                 <a:ea typeface="Arial" pitchFamily="34" charset="-122"/>
                 <a:cs typeface="Arial" pitchFamily="34" charset="-120"/>
               </a:rPr>
-              <a:t>Anthropic API with live web search · TheirStack job-post technographics · secret-link calendar feeds · HubSpot private-app sync · Docker self-host or cloud</a:t>
+              <a:t>Anthropic API with live web search · TheirStack technographics · SEC EDGAR + press feeds + earnings calls · Google/ICS calendar · HubSpot &amp; Salesforce sync · Docker + Postgres</a:t>
             </a:r>
             <a:endParaRPr lang="en-US" sz="1150" dirty="0"/>
           </a:p>
@@ -9221,7 +9221,7 @@
                 <a:ea typeface="Arial" pitchFamily="34" charset="-122"/>
                 <a:cs typeface="Arial" pitchFamily="34" charset="-120"/>
               </a:rPr>
-              <a:t>$39</a:t>
+              <a:t>$49</a:t>
             </a:r>
             <a:pPr indent="0" marL="0">
               <a:buNone/>
@@ -9620,7 +9620,7 @@
                 <a:ea typeface="Arial" pitchFamily="34" charset="-122"/>
                 <a:cs typeface="Arial" pitchFamily="34" charset="-120"/>
               </a:rPr>
-              <a:t>~70% gross margin at launch pricing · brief cost $0.25–1.00, cut further by 24h caching. Team tier (shared memory, admin, SSO) planned at $79/rep.</a:t>
+              <a:t>~75% gross margin at launch pricing · brief cost $0.25–1.00, cut further by 24h caching. Team tier at $79/rep — workspaces with shared memory shipped in v2.0.</a:t>
             </a:r>
             <a:endParaRPr lang="en-US" sz="1050" dirty="0"/>
           </a:p>

</xml_diff>